<commit_message>
fix: PNG bounds, Nim import/keyword, .exe skip in read phase across all languages
- Rust: fix PNG IEND offset pos+8 (was pos+12), skip .exe from read count
- Go: fix PNG IEND offset pos+8 with bounds check
- Nim: fix PNG IEND offset pos+8, add sequtils import, rename 'new' var,
      skip .exe from read count, fix indentation
- C, C++: skip .exe from read count
</commit_message>
<xml_diff>
--- a/go/creeper/presentacion.pptx
+++ b/go/creeper/presentacion.pptx
@@ -10,4 +10,11 @@
 </file>
 
 <file path=ppt/slides/slide1.xml><?xml version="1.0" encoding="UTF-8" standalone="yes"?><p:sld xmlns:p="http://schemas.openxmlformats.org/presentationml/2006/main"><p:cSld><p:spTree><p:nvGrpSpPr><p:nvPr><p:cNvPr id="1" name=""/></p:nvPr></p:nvGrpSpPr><p:grpSpPr><a:xfrm xmlns:a="http://schemas.openxmlformats.org/drawingml/2006/main"><a:off x="0" y="0"/><a:ext cx="0" cy="0"/></a:xfrm></p:grpSpPr><p:sp><p:nvSpPr><p:cNvPr id="2" name="Title"/><p:nvSpPrType spPr="true"/></p:nvSpPr><p:spPr><a:xfrm xmlns:a="http://schemas.openxmlformats.org/drawingml/2006/main"><a:off x="685800" y="457200"/><a:ext cx="7772400" cy="1219200"/></a:xfrm></p:spPr><p:txBody><a:bodyPr/><a:p><a:r><a:rPr lang="es-AR" sz="4400"/><a:t>Creeper Virus Lab</a:t></a:r></a:p></p:txBody></p:sp></p:spTree></p:cSld></p:sld>
+</file>
+
+<file path=creeper_infection/.creeper_marker.txt>CREEPER VIRUS - INFECTION MARKER
+Timestamp: 2026-07-09 14:31:31
+Original file: presentacion.pptx
+This file was infected by the Creeper educational virus.
+
 </file>
</xml_diff>

<commit_message>
chore: limpieza completa + README global
- Limpia todos los directorios creeper/ (elimina infection.log, RTL clones, .exe, .o)
- Regenera 12 archivos de usuario limpios en cada directorio
- Agrega .gitignore (__pycache__, *.exe, infection.log, *.o)
- Elimina docs/docs.md obsoleto, docs/ vacío
- Elimina rust/access direct/ (directorio huérfano)
- README.md completo con instrucciones en español para los 6 lenguajes
</commit_message>
<xml_diff>
--- a/go/creeper/presentacion.pptx
+++ b/go/creeper/presentacion.pptx
@@ -10,11 +10,4 @@
 </file>
 
 <file path=ppt/slides/slide1.xml><?xml version="1.0" encoding="UTF-8" standalone="yes"?><p:sld xmlns:p="http://schemas.openxmlformats.org/presentationml/2006/main"><p:cSld><p:spTree><p:nvGrpSpPr><p:nvPr><p:cNvPr id="1" name=""/></p:nvPr></p:nvGrpSpPr><p:grpSpPr><a:xfrm xmlns:a="http://schemas.openxmlformats.org/drawingml/2006/main"><a:off x="0" y="0"/><a:ext cx="0" cy="0"/></a:xfrm></p:grpSpPr><p:sp><p:nvSpPr><p:cNvPr id="2" name="Title"/><p:nvSpPrType spPr="true"/></p:nvSpPr><p:spPr><a:xfrm xmlns:a="http://schemas.openxmlformats.org/drawingml/2006/main"><a:off x="685800" y="457200"/><a:ext cx="7772400" cy="1219200"/></a:xfrm></p:spPr><p:txBody><a:bodyPr/><a:p><a:r><a:rPr lang="es-AR" sz="4400"/><a:t>Creeper Virus Lab</a:t></a:r></a:p></p:txBody></p:sp></p:spTree></p:cSld></p:sld>
-</file>
-
-<file path=creeper_infection/.creeper_marker.txt>CREEPER VIRUS - INFECTION MARKER
-Timestamp: 2026-07-09 14:31:31
-Original file: presentacion.pptx
-This file was infected by the Creeper educational virus.
-
 </file>
</xml_diff>